<commit_message>
Preenche o celular da responsavel
Celular (11) 94755-1771, informado pelo cliente. E campo obrigatorio na
janela Adicionar Usuario, entao sem ele o cadastro da Rota A nao conclui.
Entra como constante NL_CELULAR e aparece no slide 10 (dados a digitar) e no
slide 21 (contato), substituindo o [INSERIR TELEFONE] que estava la.

Nao ha mais nenhum marcador [INSERIR] no deck. Seguem apenas os [CONFIRMAR]
dos slides 11 e 13 e o [PRINT PENDENTE] do slide 15, que dependem de
informacao que nao temos como verificar.
</commit_message>
<xml_diff>
--- a/apresentacoes/sinir_mtr/Nunes_Lucato_MTR_Login_Unico_Govbr.pptx
+++ b/apresentacoes/sinir_mtr/Nunes_Lucato_MTR_Login_Unico_Govbr.pptx
@@ -6832,7 +6832,7 @@
                 </a:solidFill>
                 <a:latin typeface="Montserrat SemiBold"/>
               </a:rPr>
-              <a:t>[INSERIR CELULAR]</a:t>
+              <a:t>(11) 94755-1771</a:t>
             </a:r>
           </a:p>
         </p:txBody>
@@ -7213,7 +7213,7 @@
                 </a:solidFill>
                 <a:latin typeface="Montserrat"/>
               </a:rPr>
-              <a:t>O CPF é o que liga a conta Gov.br dela à sua unidade: um dígito errado impede o vínculo. Os campos marcados com asterisco são obrigatórios.</a:t>
+              <a:t>Os cinco campos acima são os obrigatórios (marcados com asterisco no sistema). O CPF é o que liga a conta Gov.br dela à sua unidade: um dígito errado impede o vínculo.</a:t>
             </a:r>
           </a:p>
         </p:txBody>
@@ -29155,7 +29155,7 @@
                 </a:solidFill>
                 <a:latin typeface="Montserrat SemiBold"/>
               </a:rPr>
-              <a:t>[INSERIR TELEFONE]</a:t>
+              <a:t>(11) 94755-1771</a:t>
             </a:r>
           </a:p>
         </p:txBody>

</xml_diff>